<commit_message>
Add appendix slide with glossary and OEM v0 checklists
Slide 13 documents key briefing terms (air cover, overlay, pre-flight,
etc.) and starter GM/VW/Ford pre-Propose checklists for Q&A. Rebuild
web viewer assets to 13 slides.

Co-authored-by: rockyforever8-sys <rockyforever8-sys@users.noreply.github.com>
</commit_message>
<xml_diff>
--- a/docs/IMDS_Agentic_Workflow.pptx
+++ b/docs/IMDS_Agentic_Workflow.pptx
@@ -17,6 +17,7 @@
     <p:sldId id="265" r:id="rId17"/>
     <p:sldId id="266" r:id="rId18"/>
     <p:sldId id="267" r:id="rId19"/>
+    <p:sldId id="268" r:id="rId20"/>
   </p:sldIdLst>
   <p:sldSz cx="12191695" cy="6858000" type="screen4x3"/>
   <p:notesSz cx="6858000" cy="9144000"/>
@@ -724,6 +725,76 @@
           <a:p>
             <a:r>
               <a:t>16:30–18:00 then stop for questions (2 min buffer). Read the four asks. Close on the gold bar — do not add a new idea. If they ask budget, say own effort only. If they ask headcount, say role redesign not reduction. If they ask buy vs build, say build; vendors are evidence. Leave silence after the last line so VP/GM can endorse.</a:t>
+            </a:r>
+          </a:p>
+        </p:txBody>
+      </p:sp>
+      <p:sp>
+        <p:nvSpPr>
+          <p:cNvPr id="4" name="Slide Number Placeholder 3"/>
+          <p:cNvSpPr>
+            <a:spLocks noGrp="1"/>
+          </p:cNvSpPr>
+          <p:nvPr>
+            <p:ph type="sldNum" idx="5" sz="quarter"/>
+          </p:nvPr>
+        </p:nvSpPr>
+        <p:spPr/>
+      </p:sp>
+    </p:spTree>
+  </p:cSld>
+  <p:clrMapOvr>
+    <a:masterClrMapping/>
+  </p:clrMapOvr>
+</p:notes>
+</file>
+
+<file path=ppt/notesSlides/notesSlide13.xml><?xml version="1.0" encoding="utf-8"?>
+<p:notes xmlns:a="http://schemas.openxmlformats.org/drawingml/2006/main" xmlns:p="http://schemas.openxmlformats.org/presentationml/2006/main" xmlns:r="http://schemas.openxmlformats.org/officeDocument/2006/relationships">
+  <p:cSld>
+    <p:spTree>
+      <p:nvGrpSpPr>
+        <p:cNvPr id="1" name=""/>
+        <p:cNvGrpSpPr/>
+        <p:nvPr/>
+      </p:nvGrpSpPr>
+      <p:grpSpPr>
+        <a:xfrm>
+          <a:off x="0" y="0"/>
+          <a:ext cx="0" cy="0"/>
+          <a:chOff x="0" y="0"/>
+          <a:chExt cx="0" cy="0"/>
+        </a:xfrm>
+      </p:grpSpPr>
+      <p:sp>
+        <p:nvSpPr>
+          <p:cNvPr id="2" name="Slide Image Placeholder 1"/>
+          <p:cNvSpPr>
+            <a:spLocks noGrp="1"/>
+          </p:cNvSpPr>
+          <p:nvPr>
+            <p:ph type="sldImg" idx="2"/>
+          </p:nvPr>
+        </p:nvSpPr>
+        <p:spPr/>
+      </p:sp>
+      <p:sp>
+        <p:nvSpPr>
+          <p:cNvPr id="3" name="Notes Placeholder 2"/>
+          <p:cNvSpPr>
+            <a:spLocks noGrp="1"/>
+          </p:cNvSpPr>
+          <p:nvPr>
+            <p:ph type="body" idx="3" sz="quarter"/>
+          </p:nvPr>
+        </p:nvSpPr>
+        <p:spPr/>
+        <p:txBody>
+          <a:bodyPr/>
+          <a:lstStyle/>
+          <a:p>
+            <a:r>
+              <a:t>Appendix — use only if asked in Q&amp;A; do not present in the 20-minute slot unless someone asks for definitions. Full elaboration: Air cover = VP/GM publicly defends automation. Parallel inbox = hiring without encoding rules. Directed buy example: GM directs Tier-2 bracket; they Propose to GM and to us. Dummy child chase = email sub-suppliers with missing accepted child MDS. Orphan decision = audit cannot replay which rule version applied. Amber examples: weight near limit, new supplier. Novel: derogation, new chemistry. OEM-rule owner job description: maintain rule packs, audit auto-greens, coach suppliers. Sources: public.mdsystem.com OEM guides, GMW3059, VW 91101, Ford RSMS.</a:t>
             </a:r>
           </a:p>
         </p:txBody>
@@ -6218,7 +6289,7 @@
                 </a:solidFill>
                 <a:latin typeface="Calibri"/>
               </a:rPr>
-              <a:t>10  /  12</a:t>
+              <a:t>10  /  13</a:t>
             </a:r>
           </a:p>
         </p:txBody>
@@ -7647,7 +7718,7 @@
                 </a:solidFill>
                 <a:latin typeface="Calibri"/>
               </a:rPr>
-              <a:t>11  /  12</a:t>
+              <a:t>11  /  13</a:t>
             </a:r>
           </a:p>
         </p:txBody>
@@ -8967,7 +9038,2268 @@
                 </a:solidFill>
                 <a:latin typeface="Calibri"/>
               </a:rPr>
-              <a:t>12  /  12</a:t>
+              <a:t>12  /  13</a:t>
+            </a:r>
+          </a:p>
+        </p:txBody>
+      </p:sp>
+    </p:spTree>
+  </p:cSld>
+  <p:clrMapOvr>
+    <a:masterClrMapping/>
+  </p:clrMapOvr>
+</p:sld>
+</file>
+
+<file path=ppt/slides/slide13.xml><?xml version="1.0" encoding="utf-8"?>
+<p:sld xmlns:a="http://schemas.openxmlformats.org/drawingml/2006/main" xmlns:p="http://schemas.openxmlformats.org/presentationml/2006/main" xmlns:r="http://schemas.openxmlformats.org/officeDocument/2006/relationships">
+  <p:cSld>
+    <p:spTree>
+      <p:nvGrpSpPr>
+        <p:cNvPr id="1" name=""/>
+        <p:cNvGrpSpPr/>
+        <p:nvPr/>
+      </p:nvGrpSpPr>
+      <p:grpSpPr/>
+      <p:sp>
+        <p:nvSpPr>
+          <p:cNvPr id="2" name="Rectangle 1"/>
+          <p:cNvSpPr/>
+          <p:nvPr/>
+        </p:nvSpPr>
+        <p:spPr>
+          <a:xfrm>
+            <a:off x="0" y="0"/>
+            <a:ext cx="12191695" cy="6858000"/>
+          </a:xfrm>
+          <a:prstGeom prst="rect">
+            <a:avLst/>
+          </a:prstGeom>
+          <a:solidFill>
+            <a:srgbClr val="FFFFFF"/>
+          </a:solidFill>
+          <a:ln>
+            <a:noFill/>
+          </a:ln>
+        </p:spPr>
+        <p:style>
+          <a:lnRef idx="1">
+            <a:schemeClr val="accent1"/>
+          </a:lnRef>
+          <a:fillRef idx="3">
+            <a:schemeClr val="accent1"/>
+          </a:fillRef>
+          <a:effectRef idx="2">
+            <a:schemeClr val="accent1"/>
+          </a:effectRef>
+          <a:fontRef idx="minor">
+            <a:schemeClr val="lt1"/>
+          </a:fontRef>
+        </p:style>
+        <p:txBody>
+          <a:bodyPr rtlCol="0" anchor="ctr"/>
+          <a:lstStyle/>
+          <a:p>
+            <a:pPr algn="ctr"/>
+          </a:p>
+        </p:txBody>
+      </p:sp>
+      <p:sp>
+        <p:nvSpPr>
+          <p:cNvPr id="3" name="Rectangle 2"/>
+          <p:cNvSpPr/>
+          <p:nvPr/>
+        </p:nvSpPr>
+        <p:spPr>
+          <a:xfrm>
+            <a:off x="0" y="0"/>
+            <a:ext cx="12191695" cy="1060704"/>
+          </a:xfrm>
+          <a:prstGeom prst="rect">
+            <a:avLst/>
+          </a:prstGeom>
+          <a:solidFill>
+            <a:srgbClr val="0B1F3A"/>
+          </a:solidFill>
+          <a:ln>
+            <a:noFill/>
+          </a:ln>
+        </p:spPr>
+        <p:style>
+          <a:lnRef idx="1">
+            <a:schemeClr val="accent1"/>
+          </a:lnRef>
+          <a:fillRef idx="3">
+            <a:schemeClr val="accent1"/>
+          </a:fillRef>
+          <a:effectRef idx="2">
+            <a:schemeClr val="accent1"/>
+          </a:effectRef>
+          <a:fontRef idx="minor">
+            <a:schemeClr val="lt1"/>
+          </a:fontRef>
+        </p:style>
+        <p:txBody>
+          <a:bodyPr rtlCol="0" anchor="ctr"/>
+          <a:lstStyle/>
+          <a:p>
+            <a:pPr algn="ctr"/>
+          </a:p>
+        </p:txBody>
+      </p:sp>
+      <p:sp>
+        <p:nvSpPr>
+          <p:cNvPr id="4" name="Rectangle 3"/>
+          <p:cNvSpPr/>
+          <p:nvPr/>
+        </p:nvSpPr>
+        <p:spPr>
+          <a:xfrm>
+            <a:off x="0" y="1060704"/>
+            <a:ext cx="12191695" cy="14000"/>
+          </a:xfrm>
+          <a:prstGeom prst="rect">
+            <a:avLst/>
+          </a:prstGeom>
+          <a:solidFill>
+            <a:srgbClr val="C4A35A"/>
+          </a:solidFill>
+          <a:ln>
+            <a:noFill/>
+          </a:ln>
+        </p:spPr>
+        <p:style>
+          <a:lnRef idx="1">
+            <a:schemeClr val="accent1"/>
+          </a:lnRef>
+          <a:fillRef idx="3">
+            <a:schemeClr val="accent1"/>
+          </a:fillRef>
+          <a:effectRef idx="2">
+            <a:schemeClr val="accent1"/>
+          </a:effectRef>
+          <a:fontRef idx="minor">
+            <a:schemeClr val="lt1"/>
+          </a:fontRef>
+        </p:style>
+        <p:txBody>
+          <a:bodyPr rtlCol="0" anchor="ctr"/>
+          <a:lstStyle/>
+          <a:p>
+            <a:pPr algn="ctr"/>
+          </a:p>
+        </p:txBody>
+      </p:sp>
+      <p:sp>
+        <p:nvSpPr>
+          <p:cNvPr id="5" name="TextBox 4"/>
+          <p:cNvSpPr txBox="1"/>
+          <p:nvPr/>
+        </p:nvSpPr>
+        <p:spPr>
+          <a:xfrm>
+            <a:off x="457200" y="91440"/>
+            <a:ext cx="11247120" cy="201168"/>
+          </a:xfrm>
+          <a:prstGeom prst="rect">
+            <a:avLst/>
+          </a:prstGeom>
+          <a:noFill/>
+        </p:spPr>
+        <p:txBody>
+          <a:bodyPr wrap="square"/>
+          <a:lstStyle/>
+          <a:p>
+            <a:pPr algn="l">
+              <a:spcBef>
+                <a:spcPts val="0"/>
+              </a:spcBef>
+              <a:spcAft>
+                <a:spcPts val="600"/>
+              </a:spcAft>
+            </a:pPr>
+            <a:r>
+              <a:rPr sz="1000" b="1" i="0">
+                <a:solidFill>
+                  <a:srgbClr val="C4A35A"/>
+                </a:solidFill>
+                <a:latin typeface="Calibri"/>
+              </a:rPr>
+              <a:t>APPENDIX</a:t>
+            </a:r>
+          </a:p>
+        </p:txBody>
+      </p:sp>
+      <p:sp>
+        <p:nvSpPr>
+          <p:cNvPr id="6" name="TextBox 5"/>
+          <p:cNvSpPr txBox="1"/>
+          <p:nvPr/>
+        </p:nvSpPr>
+        <p:spPr>
+          <a:xfrm>
+            <a:off x="457200" y="292608"/>
+            <a:ext cx="11247120" cy="365760"/>
+          </a:xfrm>
+          <a:prstGeom prst="rect">
+            <a:avLst/>
+          </a:prstGeom>
+          <a:noFill/>
+        </p:spPr>
+        <p:txBody>
+          <a:bodyPr wrap="square"/>
+          <a:lstStyle/>
+          <a:p>
+            <a:pPr algn="l">
+              <a:spcBef>
+                <a:spcPts val="0"/>
+              </a:spcBef>
+              <a:spcAft>
+                <a:spcPts val="600"/>
+              </a:spcAft>
+            </a:pPr>
+            <a:r>
+              <a:rPr sz="2200" b="1" i="0">
+                <a:solidFill>
+                  <a:srgbClr val="FFFFFF"/>
+                </a:solidFill>
+                <a:latin typeface="Calibri"/>
+              </a:rPr>
+              <a:t>Glossary and v0 OEM checklists</a:t>
+            </a:r>
+          </a:p>
+        </p:txBody>
+      </p:sp>
+      <p:sp>
+        <p:nvSpPr>
+          <p:cNvPr id="7" name="TextBox 6"/>
+          <p:cNvSpPr txBox="1"/>
+          <p:nvPr/>
+        </p:nvSpPr>
+        <p:spPr>
+          <a:xfrm>
+            <a:off x="457200" y="676656"/>
+            <a:ext cx="11247120" cy="329184"/>
+          </a:xfrm>
+          <a:prstGeom prst="rect">
+            <a:avLst/>
+          </a:prstGeom>
+          <a:noFill/>
+        </p:spPr>
+        <p:txBody>
+          <a:bodyPr wrap="square"/>
+          <a:lstStyle/>
+          <a:p>
+            <a:pPr algn="l">
+              <a:spcBef>
+                <a:spcPts val="0"/>
+              </a:spcBef>
+              <a:spcAft>
+                <a:spcPts val="600"/>
+              </a:spcAft>
+            </a:pPr>
+            <a:r>
+              <a:rPr sz="1200" b="0" i="0">
+                <a:solidFill>
+                  <a:srgbClr val="C5D0DC"/>
+                </a:solidFill>
+                <a:latin typeface="Calibri"/>
+              </a:rPr>
+              <a:t>Reference for Q&amp;A. Validate against current GM / VW / Ford IMDS portals before production use.</a:t>
+            </a:r>
+          </a:p>
+        </p:txBody>
+      </p:sp>
+      <p:graphicFrame>
+        <p:nvGraphicFramePr>
+          <p:cNvPr id="8" name="Table 7"/>
+          <p:cNvGraphicFramePr>
+            <a:graphicFrameLocks noGrp="1"/>
+          </p:cNvGraphicFramePr>
+          <p:nvPr/>
+        </p:nvGraphicFramePr>
+        <p:xfrm>
+          <a:off x="411480" y="1024128"/>
+          <a:ext cx="11338560" cy="2331720"/>
+        </p:xfrm>
+        <a:graphic>
+          <a:graphicData uri="http://schemas.openxmlformats.org/drawingml/2006/table">
+            <a:tbl>
+              <a:tblPr firstRow="1" bandRow="1">
+                <a:tableStyleId>{5C22544A-7EE6-4342-B048-85BDC9FD1C3A}</a:tableStyleId>
+              </a:tblPr>
+              <a:tblGrid>
+                <a:gridCol w="1417320"/>
+                <a:gridCol w="4251960"/>
+                <a:gridCol w="1417320"/>
+                <a:gridCol w="4251960"/>
+              </a:tblGrid>
+              <a:tr h="291465">
+                <a:tc>
+                  <a:txBody>
+                    <a:bodyPr wrap="square"/>
+                    <a:lstStyle/>
+                    <a:p>
+                      <a:pPr algn="ctr">
+                        <a:spcBef>
+                          <a:spcPts val="200"/>
+                        </a:spcBef>
+                        <a:spcAft>
+                          <a:spcPts val="200"/>
+                        </a:spcAft>
+                      </a:pPr>
+                      <a:r>
+                        <a:rPr sz="1000" b="1" i="0">
+                          <a:solidFill>
+                            <a:srgbClr val="FFFFFF"/>
+                          </a:solidFill>
+                          <a:latin typeface="Calibri"/>
+                        </a:rPr>
+                        <a:t>Term</a:t>
+                      </a:r>
+                    </a:p>
+                  </a:txBody>
+                  <a:tcPr>
+                    <a:solidFill>
+                      <a:srgbClr val="0B1F3A"/>
+                    </a:solidFill>
+                  </a:tcPr>
+                </a:tc>
+                <a:tc>
+                  <a:txBody>
+                    <a:bodyPr wrap="square"/>
+                    <a:lstStyle/>
+                    <a:p>
+                      <a:pPr algn="ctr">
+                        <a:spcBef>
+                          <a:spcPts val="200"/>
+                        </a:spcBef>
+                        <a:spcAft>
+                          <a:spcPts val="200"/>
+                        </a:spcAft>
+                      </a:pPr>
+                      <a:r>
+                        <a:rPr sz="1000" b="1" i="0">
+                          <a:solidFill>
+                            <a:srgbClr val="FFFFFF"/>
+                          </a:solidFill>
+                          <a:latin typeface="Calibri"/>
+                        </a:rPr>
+                        <a:t>Meaning</a:t>
+                      </a:r>
+                    </a:p>
+                  </a:txBody>
+                  <a:tcPr>
+                    <a:solidFill>
+                      <a:srgbClr val="0B1F3A"/>
+                    </a:solidFill>
+                  </a:tcPr>
+                </a:tc>
+                <a:tc>
+                  <a:txBody>
+                    <a:bodyPr wrap="square"/>
+                    <a:lstStyle/>
+                    <a:p>
+                      <a:pPr algn="ctr">
+                        <a:spcBef>
+                          <a:spcPts val="200"/>
+                        </a:spcBef>
+                        <a:spcAft>
+                          <a:spcPts val="200"/>
+                        </a:spcAft>
+                      </a:pPr>
+                      <a:r>
+                        <a:rPr sz="1000" b="1" i="0">
+                          <a:solidFill>
+                            <a:srgbClr val="FFFFFF"/>
+                          </a:solidFill>
+                          <a:latin typeface="Calibri"/>
+                        </a:rPr>
+                        <a:t>Term</a:t>
+                      </a:r>
+                    </a:p>
+                  </a:txBody>
+                  <a:tcPr>
+                    <a:solidFill>
+                      <a:srgbClr val="0B1F3A"/>
+                    </a:solidFill>
+                  </a:tcPr>
+                </a:tc>
+                <a:tc>
+                  <a:txBody>
+                    <a:bodyPr wrap="square"/>
+                    <a:lstStyle/>
+                    <a:p>
+                      <a:pPr algn="ctr">
+                        <a:spcBef>
+                          <a:spcPts val="200"/>
+                        </a:spcBef>
+                        <a:spcAft>
+                          <a:spcPts val="200"/>
+                        </a:spcAft>
+                      </a:pPr>
+                      <a:r>
+                        <a:rPr sz="1000" b="1" i="0">
+                          <a:solidFill>
+                            <a:srgbClr val="FFFFFF"/>
+                          </a:solidFill>
+                          <a:latin typeface="Calibri"/>
+                        </a:rPr>
+                        <a:t>Meaning</a:t>
+                      </a:r>
+                    </a:p>
+                  </a:txBody>
+                  <a:tcPr>
+                    <a:solidFill>
+                      <a:srgbClr val="0B1F3A"/>
+                    </a:solidFill>
+                  </a:tcPr>
+                </a:tc>
+              </a:tr>
+              <a:tr h="291465">
+                <a:tc>
+                  <a:txBody>
+                    <a:bodyPr wrap="square"/>
+                    <a:lstStyle/>
+                    <a:p>
+                      <a:pPr algn="l">
+                        <a:spcBef>
+                          <a:spcPts val="200"/>
+                        </a:spcBef>
+                        <a:spcAft>
+                          <a:spcPts val="200"/>
+                        </a:spcAft>
+                      </a:pPr>
+                      <a:r>
+                        <a:rPr sz="900" b="1" i="0">
+                          <a:solidFill>
+                            <a:srgbClr val="0B1F3A"/>
+                          </a:solidFill>
+                          <a:latin typeface="Calibri"/>
+                        </a:rPr>
+                        <a:t>Air cover</a:t>
+                      </a:r>
+                    </a:p>
+                  </a:txBody>
+                  <a:tcPr>
+                    <a:solidFill>
+                      <a:srgbClr val="F8F1E0"/>
+                    </a:solidFill>
+                  </a:tcPr>
+                </a:tc>
+                <a:tc>
+                  <a:txBody>
+                    <a:bodyPr wrap="square"/>
+                    <a:lstStyle/>
+                    <a:p>
+                      <a:pPr algn="l">
+                        <a:spcBef>
+                          <a:spcPts val="200"/>
+                        </a:spcBef>
+                        <a:spcAft>
+                          <a:spcPts val="200"/>
+                        </a:spcAft>
+                      </a:pPr>
+                      <a:r>
+                        <a:rPr sz="900" b="0" i="0">
+                          <a:solidFill>
+                            <a:srgbClr val="3A4758"/>
+                          </a:solidFill>
+                          <a:latin typeface="Calibri"/>
+                        </a:rPr>
+                        <a:t>Leadership backs SQ to automate without reopening buy/hire every week.</a:t>
+                      </a:r>
+                    </a:p>
+                  </a:txBody>
+                  <a:tcPr>
+                    <a:solidFill>
+                      <a:srgbClr val="FFFFFF"/>
+                    </a:solidFill>
+                  </a:tcPr>
+                </a:tc>
+                <a:tc>
+                  <a:txBody>
+                    <a:bodyPr wrap="square"/>
+                    <a:lstStyle/>
+                    <a:p>
+                      <a:pPr algn="l">
+                        <a:spcBef>
+                          <a:spcPts val="200"/>
+                        </a:spcBef>
+                        <a:spcAft>
+                          <a:spcPts val="200"/>
+                        </a:spcAft>
+                      </a:pPr>
+                      <a:r>
+                        <a:rPr sz="900" b="1" i="0">
+                          <a:solidFill>
+                            <a:srgbClr val="0B1F3A"/>
+                          </a:solidFill>
+                          <a:latin typeface="Calibri"/>
+                        </a:rPr>
+                        <a:t>Parallel inbox</a:t>
+                      </a:r>
+                    </a:p>
+                  </a:txBody>
+                  <a:tcPr>
+                    <a:solidFill>
+                      <a:srgbClr val="F8F1E0"/>
+                    </a:solidFill>
+                  </a:tcPr>
+                </a:tc>
+                <a:tc>
+                  <a:txBody>
+                    <a:bodyPr wrap="square"/>
+                    <a:lstStyle/>
+                    <a:p>
+                      <a:pPr algn="l">
+                        <a:spcBef>
+                          <a:spcPts val="200"/>
+                        </a:spcBef>
+                        <a:spcAft>
+                          <a:spcPts val="200"/>
+                        </a:spcAft>
+                      </a:pPr>
+                      <a:r>
+                        <a:rPr sz="900" b="0" i="0">
+                          <a:solidFill>
+                            <a:srgbClr val="3A4758"/>
+                          </a:solidFill>
+                          <a:latin typeface="Calibri"/>
+                        </a:rPr>
+                        <a:t>Hire more people to do the same manual view/accept/reject work.</a:t>
+                      </a:r>
+                    </a:p>
+                  </a:txBody>
+                  <a:tcPr>
+                    <a:solidFill>
+                      <a:srgbClr val="FFFFFF"/>
+                    </a:solidFill>
+                  </a:tcPr>
+                </a:tc>
+              </a:tr>
+              <a:tr h="291465">
+                <a:tc>
+                  <a:txBody>
+                    <a:bodyPr wrap="square"/>
+                    <a:lstStyle/>
+                    <a:p>
+                      <a:pPr algn="l">
+                        <a:spcBef>
+                          <a:spcPts val="200"/>
+                        </a:spcBef>
+                        <a:spcAft>
+                          <a:spcPts val="200"/>
+                        </a:spcAft>
+                      </a:pPr>
+                      <a:r>
+                        <a:rPr sz="900" b="1" i="0">
+                          <a:solidFill>
+                            <a:srgbClr val="0B1F3A"/>
+                          </a:solidFill>
+                          <a:latin typeface="Calibri"/>
+                        </a:rPr>
+                        <a:t>PCF</a:t>
+                      </a:r>
+                    </a:p>
+                  </a:txBody>
+                  <a:tcPr>
+                    <a:solidFill>
+                      <a:srgbClr val="F5F7F9"/>
+                    </a:solidFill>
+                  </a:tcPr>
+                </a:tc>
+                <a:tc>
+                  <a:txBody>
+                    <a:bodyPr wrap="square"/>
+                    <a:lstStyle/>
+                    <a:p>
+                      <a:pPr algn="l">
+                        <a:spcBef>
+                          <a:spcPts val="200"/>
+                        </a:spcBef>
+                        <a:spcAft>
+                          <a:spcPts val="200"/>
+                        </a:spcAft>
+                      </a:pPr>
+                      <a:r>
+                        <a:rPr sz="900" b="0" i="0">
+                          <a:solidFill>
+                            <a:srgbClr val="3A4758"/>
+                          </a:solidFill>
+                          <a:latin typeface="Calibri"/>
+                        </a:rPr>
+                        <a:t>Product Carbon Footprint — emissions per part (Rec 027; not in v1).</a:t>
+                      </a:r>
+                    </a:p>
+                  </a:txBody>
+                  <a:tcPr>
+                    <a:solidFill>
+                      <a:srgbClr val="F5F7F9"/>
+                    </a:solidFill>
+                  </a:tcPr>
+                </a:tc>
+                <a:tc>
+                  <a:txBody>
+                    <a:bodyPr wrap="square"/>
+                    <a:lstStyle/>
+                    <a:p>
+                      <a:pPr algn="l">
+                        <a:spcBef>
+                          <a:spcPts val="200"/>
+                        </a:spcBef>
+                        <a:spcAft>
+                          <a:spcPts val="200"/>
+                        </a:spcAft>
+                      </a:pPr>
+                      <a:r>
+                        <a:rPr sz="900" b="1" i="0">
+                          <a:solidFill>
+                            <a:srgbClr val="0B1F3A"/>
+                          </a:solidFill>
+                          <a:latin typeface="Calibri"/>
+                        </a:rPr>
+                        <a:t>Directed buy</a:t>
+                      </a:r>
+                    </a:p>
+                  </a:txBody>
+                  <a:tcPr>
+                    <a:solidFill>
+                      <a:srgbClr val="F5F7F9"/>
+                    </a:solidFill>
+                  </a:tcPr>
+                </a:tc>
+                <a:tc>
+                  <a:txBody>
+                    <a:bodyPr wrap="square"/>
+                    <a:lstStyle/>
+                    <a:p>
+                      <a:pPr algn="l">
+                        <a:spcBef>
+                          <a:spcPts val="200"/>
+                        </a:spcBef>
+                        <a:spcAft>
+                          <a:spcPts val="200"/>
+                        </a:spcAft>
+                      </a:pPr>
+                      <a:r>
+                        <a:rPr sz="900" b="0" i="0">
+                          <a:solidFill>
+                            <a:srgbClr val="3A4758"/>
+                          </a:solidFill>
+                          <a:latin typeface="Calibri"/>
+                        </a:rPr>
+                        <a:t>OEM nominates sub-supplier; lower tier Proposes to OEM and to you.</a:t>
+                      </a:r>
+                    </a:p>
+                  </a:txBody>
+                  <a:tcPr>
+                    <a:solidFill>
+                      <a:srgbClr val="F5F7F9"/>
+                    </a:solidFill>
+                  </a:tcPr>
+                </a:tc>
+              </a:tr>
+              <a:tr h="291465">
+                <a:tc>
+                  <a:txBody>
+                    <a:bodyPr wrap="square"/>
+                    <a:lstStyle/>
+                    <a:p>
+                      <a:pPr algn="l">
+                        <a:spcBef>
+                          <a:spcPts val="200"/>
+                        </a:spcBef>
+                        <a:spcAft>
+                          <a:spcPts val="200"/>
+                        </a:spcAft>
+                      </a:pPr>
+                      <a:r>
+                        <a:rPr sz="900" b="1" i="0">
+                          <a:solidFill>
+                            <a:srgbClr val="0B1F3A"/>
+                          </a:solidFill>
+                          <a:latin typeface="Calibri"/>
+                        </a:rPr>
+                        <a:t>Overlay</a:t>
+                      </a:r>
+                    </a:p>
+                  </a:txBody>
+                  <a:tcPr>
+                    <a:solidFill>
+                      <a:srgbClr val="F8F1E0"/>
+                    </a:solidFill>
+                  </a:tcPr>
+                </a:tc>
+                <a:tc>
+                  <a:txBody>
+                    <a:bodyPr wrap="square"/>
+                    <a:lstStyle/>
+                    <a:p>
+                      <a:pPr algn="l">
+                        <a:spcBef>
+                          <a:spcPts val="200"/>
+                        </a:spcBef>
+                        <a:spcAft>
+                          <a:spcPts val="200"/>
+                        </a:spcAft>
+                      </a:pPr>
+                      <a:r>
+                        <a:rPr sz="900" b="0" i="0">
+                          <a:solidFill>
+                            <a:srgbClr val="3A4758"/>
+                          </a:solidFill>
+                          <a:latin typeface="Calibri"/>
+                        </a:rPr>
+                        <a:t>OEM-specific rules on top of Rec 001 + IMDS Check.</a:t>
+                      </a:r>
+                    </a:p>
+                  </a:txBody>
+                  <a:tcPr>
+                    <a:solidFill>
+                      <a:srgbClr val="FFFFFF"/>
+                    </a:solidFill>
+                  </a:tcPr>
+                </a:tc>
+                <a:tc>
+                  <a:txBody>
+                    <a:bodyPr wrap="square"/>
+                    <a:lstStyle/>
+                    <a:p>
+                      <a:pPr algn="l">
+                        <a:spcBef>
+                          <a:spcPts val="200"/>
+                        </a:spcBef>
+                        <a:spcAft>
+                          <a:spcPts val="200"/>
+                        </a:spcAft>
+                      </a:pPr>
+                      <a:r>
+                        <a:rPr sz="900" b="1" i="0">
+                          <a:solidFill>
+                            <a:srgbClr val="0B1F3A"/>
+                          </a:solidFill>
+                          <a:latin typeface="Calibri"/>
+                        </a:rPr>
+                        <a:t>Deduplicate</a:t>
+                      </a:r>
+                    </a:p>
+                  </a:txBody>
+                  <a:tcPr>
+                    <a:solidFill>
+                      <a:srgbClr val="F8F1E0"/>
+                    </a:solidFill>
+                  </a:tcPr>
+                </a:tc>
+                <a:tc>
+                  <a:txBody>
+                    <a:bodyPr wrap="square"/>
+                    <a:lstStyle/>
+                    <a:p>
+                      <a:pPr algn="l">
+                        <a:spcBef>
+                          <a:spcPts val="200"/>
+                        </a:spcBef>
+                        <a:spcAft>
+                          <a:spcPts val="200"/>
+                        </a:spcAft>
+                      </a:pPr>
+                      <a:r>
+                        <a:rPr sz="900" b="0" i="0">
+                          <a:solidFill>
+                            <a:srgbClr val="3A4758"/>
+                          </a:solidFill>
+                          <a:latin typeface="Calibri"/>
+                        </a:rPr>
+                        <a:t>One queue item per real MDS — no double-processing resends.</a:t>
+                      </a:r>
+                    </a:p>
+                  </a:txBody>
+                  <a:tcPr>
+                    <a:solidFill>
+                      <a:srgbClr val="FFFFFF"/>
+                    </a:solidFill>
+                  </a:tcPr>
+                </a:tc>
+              </a:tr>
+              <a:tr h="291465">
+                <a:tc>
+                  <a:txBody>
+                    <a:bodyPr wrap="square"/>
+                    <a:lstStyle/>
+                    <a:p>
+                      <a:pPr algn="l">
+                        <a:spcBef>
+                          <a:spcPts val="200"/>
+                        </a:spcBef>
+                        <a:spcAft>
+                          <a:spcPts val="200"/>
+                        </a:spcAft>
+                      </a:pPr>
+                      <a:r>
+                        <a:rPr sz="900" b="1" i="0">
+                          <a:solidFill>
+                            <a:srgbClr val="0B1F3A"/>
+                          </a:solidFill>
+                          <a:latin typeface="Calibri"/>
+                        </a:rPr>
+                        <a:t>Age</a:t>
+                      </a:r>
+                    </a:p>
+                  </a:txBody>
+                  <a:tcPr>
+                    <a:solidFill>
+                      <a:srgbClr val="F5F7F9"/>
+                    </a:solidFill>
+                  </a:tcPr>
+                </a:tc>
+                <a:tc>
+                  <a:txBody>
+                    <a:bodyPr wrap="square"/>
+                    <a:lstStyle/>
+                    <a:p>
+                      <a:pPr algn="l">
+                        <a:spcBef>
+                          <a:spcPts val="200"/>
+                        </a:spcBef>
+                        <a:spcAft>
+                          <a:spcPts val="200"/>
+                        </a:spcAft>
+                      </a:pPr>
+                      <a:r>
+                        <a:rPr sz="900" b="0" i="0">
+                          <a:solidFill>
+                            <a:srgbClr val="3A4758"/>
+                          </a:solidFill>
+                          <a:latin typeface="Calibri"/>
+                        </a:rPr>
+                        <a:t>Time in status; prioritize VIP OEM parts and SLA risk.</a:t>
+                      </a:r>
+                    </a:p>
+                  </a:txBody>
+                  <a:tcPr>
+                    <a:solidFill>
+                      <a:srgbClr val="F5F7F9"/>
+                    </a:solidFill>
+                  </a:tcPr>
+                </a:tc>
+                <a:tc>
+                  <a:txBody>
+                    <a:bodyPr wrap="square"/>
+                    <a:lstStyle/>
+                    <a:p>
+                      <a:pPr algn="l">
+                        <a:spcBef>
+                          <a:spcPts val="200"/>
+                        </a:spcBef>
+                        <a:spcAft>
+                          <a:spcPts val="200"/>
+                        </a:spcAft>
+                      </a:pPr>
+                      <a:r>
+                        <a:rPr sz="900" b="1" i="0">
+                          <a:solidFill>
+                            <a:srgbClr val="0B1F3A"/>
+                          </a:solidFill>
+                          <a:latin typeface="Calibri"/>
+                        </a:rPr>
+                        <a:t>Dummy child</a:t>
+                      </a:r>
+                    </a:p>
+                  </a:txBody>
+                  <a:tcPr>
+                    <a:solidFill>
+                      <a:srgbClr val="F5F7F9"/>
+                    </a:solidFill>
+                  </a:tcPr>
+                </a:tc>
+                <a:tc>
+                  <a:txBody>
+                    <a:bodyPr wrap="square"/>
+                    <a:lstStyle/>
+                    <a:p>
+                      <a:pPr algn="l">
+                        <a:spcBef>
+                          <a:spcPts val="200"/>
+                        </a:spcBef>
+                        <a:spcAft>
+                          <a:spcPts val="200"/>
+                        </a:spcAft>
+                      </a:pPr>
+                      <a:r>
+                        <a:rPr sz="900" b="0" i="0">
+                          <a:solidFill>
+                            <a:srgbClr val="3A4758"/>
+                          </a:solidFill>
+                          <a:latin typeface="Calibri"/>
+                        </a:rPr>
+                        <a:t>Placeholder node instead of accepted sub-supplier MDS.</a:t>
+                      </a:r>
+                    </a:p>
+                  </a:txBody>
+                  <a:tcPr>
+                    <a:solidFill>
+                      <a:srgbClr val="F5F7F9"/>
+                    </a:solidFill>
+                  </a:tcPr>
+                </a:tc>
+              </a:tr>
+              <a:tr h="291465">
+                <a:tc>
+                  <a:txBody>
+                    <a:bodyPr wrap="square"/>
+                    <a:lstStyle/>
+                    <a:p>
+                      <a:pPr algn="l">
+                        <a:spcBef>
+                          <a:spcPts val="200"/>
+                        </a:spcBef>
+                        <a:spcAft>
+                          <a:spcPts val="200"/>
+                        </a:spcAft>
+                      </a:pPr>
+                      <a:r>
+                        <a:rPr sz="900" b="1" i="0">
+                          <a:solidFill>
+                            <a:srgbClr val="0B1F3A"/>
+                          </a:solidFill>
+                          <a:latin typeface="Calibri"/>
+                        </a:rPr>
+                        <a:t>Score / cite</a:t>
+                      </a:r>
+                    </a:p>
+                  </a:txBody>
+                  <a:tcPr>
+                    <a:solidFill>
+                      <a:srgbClr val="F8F1E0"/>
+                    </a:solidFill>
+                  </a:tcPr>
+                </a:tc>
+                <a:tc>
+                  <a:txBody>
+                    <a:bodyPr wrap="square"/>
+                    <a:lstStyle/>
+                    <a:p>
+                      <a:pPr algn="l">
+                        <a:spcBef>
+                          <a:spcPts val="200"/>
+                        </a:spcBef>
+                        <a:spcAft>
+                          <a:spcPts val="200"/>
+                        </a:spcAft>
+                      </a:pPr>
+                      <a:r>
+                        <a:rPr sz="900" b="0" i="0">
+                          <a:solidFill>
+                            <a:srgbClr val="3A4758"/>
+                          </a:solidFill>
+                          <a:latin typeface="Calibri"/>
+                        </a:rPr>
+                        <a:t>Rate green/amber/red; flag exact tree node and field.</a:t>
+                      </a:r>
+                    </a:p>
+                  </a:txBody>
+                  <a:tcPr>
+                    <a:solidFill>
+                      <a:srgbClr val="FFFFFF"/>
+                    </a:solidFill>
+                  </a:tcPr>
+                </a:tc>
+                <a:tc>
+                  <a:txBody>
+                    <a:bodyPr wrap="square"/>
+                    <a:lstStyle/>
+                    <a:p>
+                      <a:pPr algn="l">
+                        <a:spcBef>
+                          <a:spcPts val="200"/>
+                        </a:spcBef>
+                        <a:spcAft>
+                          <a:spcPts val="200"/>
+                        </a:spcAft>
+                      </a:pPr>
+                      <a:r>
+                        <a:rPr sz="900" b="1" i="0">
+                          <a:solidFill>
+                            <a:srgbClr val="0B1F3A"/>
+                          </a:solidFill>
+                          <a:latin typeface="Calibri"/>
+                        </a:rPr>
+                        <a:t>Structured reject</a:t>
+                      </a:r>
+                    </a:p>
+                  </a:txBody>
+                  <a:tcPr>
+                    <a:solidFill>
+                      <a:srgbClr val="F8F1E0"/>
+                    </a:solidFill>
+                  </a:tcPr>
+                </a:tc>
+                <a:tc>
+                  <a:txBody>
+                    <a:bodyPr wrap="square"/>
+                    <a:lstStyle/>
+                    <a:p>
+                      <a:pPr algn="l">
+                        <a:spcBef>
+                          <a:spcPts val="200"/>
+                        </a:spcBef>
+                        <a:spcAft>
+                          <a:spcPts val="200"/>
+                        </a:spcAft>
+                      </a:pPr>
+                      <a:r>
+                        <a:rPr sz="900" b="0" i="0">
+                          <a:solidFill>
+                            <a:srgbClr val="3A4758"/>
+                          </a:solidFill>
+                          <a:latin typeface="Calibri"/>
+                        </a:rPr>
+                        <a:t>Templated, coded reason — not “check Rec 001.”</a:t>
+                      </a:r>
+                    </a:p>
+                  </a:txBody>
+                  <a:tcPr>
+                    <a:solidFill>
+                      <a:srgbClr val="FFFFFF"/>
+                    </a:solidFill>
+                  </a:tcPr>
+                </a:tc>
+              </a:tr>
+              <a:tr h="291465">
+                <a:tc>
+                  <a:txBody>
+                    <a:bodyPr wrap="square"/>
+                    <a:lstStyle/>
+                    <a:p>
+                      <a:pPr algn="l">
+                        <a:spcBef>
+                          <a:spcPts val="200"/>
+                        </a:spcBef>
+                        <a:spcAft>
+                          <a:spcPts val="200"/>
+                        </a:spcAft>
+                      </a:pPr>
+                      <a:r>
+                        <a:rPr sz="900" b="1" i="0">
+                          <a:solidFill>
+                            <a:srgbClr val="0B1F3A"/>
+                          </a:solidFill>
+                          <a:latin typeface="Calibri"/>
+                        </a:rPr>
+                        <a:t>Pre-flight</a:t>
+                      </a:r>
+                    </a:p>
+                  </a:txBody>
+                  <a:tcPr>
+                    <a:solidFill>
+                      <a:srgbClr val="F5F7F9"/>
+                    </a:solidFill>
+                  </a:tcPr>
+                </a:tc>
+                <a:tc>
+                  <a:txBody>
+                    <a:bodyPr wrap="square"/>
+                    <a:lstStyle/>
+                    <a:p>
+                      <a:pPr algn="l">
+                        <a:spcBef>
+                          <a:spcPts val="200"/>
+                        </a:spcBef>
+                        <a:spcAft>
+                          <a:spcPts val="200"/>
+                        </a:spcAft>
+                      </a:pPr>
+                      <a:r>
+                        <a:rPr sz="900" b="0" i="0">
+                          <a:solidFill>
+                            <a:srgbClr val="3A4758"/>
+                          </a:solidFill>
+                          <a:latin typeface="Calibri"/>
+                        </a:rPr>
+                        <a:t>Run OEM pack on outbound MDS before Propose/Send.</a:t>
+                      </a:r>
+                    </a:p>
+                  </a:txBody>
+                  <a:tcPr>
+                    <a:solidFill>
+                      <a:srgbClr val="F5F7F9"/>
+                    </a:solidFill>
+                  </a:tcPr>
+                </a:tc>
+                <a:tc>
+                  <a:txBody>
+                    <a:bodyPr wrap="square"/>
+                    <a:lstStyle/>
+                    <a:p>
+                      <a:pPr algn="l">
+                        <a:spcBef>
+                          <a:spcPts val="200"/>
+                        </a:spcBef>
+                        <a:spcAft>
+                          <a:spcPts val="200"/>
+                        </a:spcAft>
+                      </a:pPr>
+                      <a:r>
+                        <a:rPr sz="900" b="1" i="0">
+                          <a:solidFill>
+                            <a:srgbClr val="0B1F3A"/>
+                          </a:solidFill>
+                          <a:latin typeface="Calibri"/>
+                        </a:rPr>
+                        <a:t>Orphan decision</a:t>
+                      </a:r>
+                    </a:p>
+                  </a:txBody>
+                  <a:tcPr>
+                    <a:solidFill>
+                      <a:srgbClr val="F5F7F9"/>
+                    </a:solidFill>
+                  </a:tcPr>
+                </a:tc>
+                <a:tc>
+                  <a:txBody>
+                    <a:bodyPr wrap="square"/>
+                    <a:lstStyle/>
+                    <a:p>
+                      <a:pPr algn="l">
+                        <a:spcBef>
+                          <a:spcPts val="200"/>
+                        </a:spcBef>
+                        <a:spcAft>
+                          <a:spcPts val="200"/>
+                        </a:spcAft>
+                      </a:pPr>
+                      <a:r>
+                        <a:rPr sz="900" b="0" i="0">
+                          <a:solidFill>
+                            <a:srgbClr val="3A4758"/>
+                          </a:solidFill>
+                          <a:latin typeface="Calibri"/>
+                        </a:rPr>
+                        <a:t>Accept/reject with no rule-pack version on record.</a:t>
+                      </a:r>
+                    </a:p>
+                  </a:txBody>
+                  <a:tcPr>
+                    <a:solidFill>
+                      <a:srgbClr val="F5F7F9"/>
+                    </a:solidFill>
+                  </a:tcPr>
+                </a:tc>
+              </a:tr>
+              <a:tr h="291465">
+                <a:tc>
+                  <a:txBody>
+                    <a:bodyPr wrap="square"/>
+                    <a:lstStyle/>
+                    <a:p>
+                      <a:pPr algn="l">
+                        <a:spcBef>
+                          <a:spcPts val="200"/>
+                        </a:spcBef>
+                        <a:spcAft>
+                          <a:spcPts val="200"/>
+                        </a:spcAft>
+                      </a:pPr>
+                      <a:r>
+                        <a:rPr sz="900" b="1" i="0">
+                          <a:solidFill>
+                            <a:srgbClr val="0B1F3A"/>
+                          </a:solidFill>
+                          <a:latin typeface="Calibri"/>
+                        </a:rPr>
+                        <a:t>Amber / novel</a:t>
+                      </a:r>
+                    </a:p>
+                  </a:txBody>
+                  <a:tcPr>
+                    <a:solidFill>
+                      <a:srgbClr val="F8F1E0"/>
+                    </a:solidFill>
+                  </a:tcPr>
+                </a:tc>
+                <a:tc>
+                  <a:txBody>
+                    <a:bodyPr wrap="square"/>
+                    <a:lstStyle/>
+                    <a:p>
+                      <a:pPr algn="l">
+                        <a:spcBef>
+                          <a:spcPts val="200"/>
+                        </a:spcBef>
+                        <a:spcAft>
+                          <a:spcPts val="200"/>
+                        </a:spcAft>
+                      </a:pPr>
+                      <a:r>
+                        <a:rPr sz="900" b="0" i="0">
+                          <a:solidFill>
+                            <a:srgbClr val="3A4758"/>
+                          </a:solidFill>
+                          <a:latin typeface="Calibri"/>
+                        </a:rPr>
+                        <a:t>Uncertain or new case — human decides, bot does not.</a:t>
+                      </a:r>
+                    </a:p>
+                  </a:txBody>
+                  <a:tcPr>
+                    <a:solidFill>
+                      <a:srgbClr val="FFFFFF"/>
+                    </a:solidFill>
+                  </a:tcPr>
+                </a:tc>
+                <a:tc>
+                  <a:txBody>
+                    <a:bodyPr wrap="square"/>
+                    <a:lstStyle/>
+                    <a:p>
+                      <a:pPr algn="l">
+                        <a:spcBef>
+                          <a:spcPts val="200"/>
+                        </a:spcBef>
+                        <a:spcAft>
+                          <a:spcPts val="200"/>
+                        </a:spcAft>
+                      </a:pPr>
+                      <a:r>
+                        <a:rPr sz="900" b="1" i="0">
+                          <a:solidFill>
+                            <a:srgbClr val="0B1F3A"/>
+                          </a:solidFill>
+                          <a:latin typeface="Calibri"/>
+                        </a:rPr>
+                        <a:t>OEM-rule owner</a:t>
+                      </a:r>
+                    </a:p>
+                  </a:txBody>
+                  <a:tcPr>
+                    <a:solidFill>
+                      <a:srgbClr val="F8F1E0"/>
+                    </a:solidFill>
+                  </a:tcPr>
+                </a:tc>
+                <a:tc>
+                  <a:txBody>
+                    <a:bodyPr wrap="square"/>
+                    <a:lstStyle/>
+                    <a:p>
+                      <a:pPr algn="l">
+                        <a:spcBef>
+                          <a:spcPts val="200"/>
+                        </a:spcBef>
+                        <a:spcAft>
+                          <a:spcPts val="200"/>
+                        </a:spcAft>
+                      </a:pPr>
+                      <a:r>
+                        <a:rPr sz="900" b="0" i="0">
+                          <a:solidFill>
+                            <a:srgbClr val="3A4758"/>
+                          </a:solidFill>
+                          <a:latin typeface="Calibri"/>
+                        </a:rPr>
+                        <a:t>Specialist owns GM/VW/Ford packs, not inbox volume.</a:t>
+                      </a:r>
+                    </a:p>
+                  </a:txBody>
+                  <a:tcPr>
+                    <a:solidFill>
+                      <a:srgbClr val="FFFFFF"/>
+                    </a:solidFill>
+                  </a:tcPr>
+                </a:tc>
+              </a:tr>
+            </a:tbl>
+          </a:graphicData>
+        </a:graphic>
+      </p:graphicFrame>
+      <p:sp>
+        <p:nvSpPr>
+          <p:cNvPr id="9" name="TextBox 8"/>
+          <p:cNvSpPr txBox="1"/>
+          <p:nvPr/>
+        </p:nvSpPr>
+        <p:spPr>
+          <a:xfrm>
+            <a:off x="457200" y="3401568"/>
+            <a:ext cx="11247120" cy="256032"/>
+          </a:xfrm>
+          <a:prstGeom prst="rect">
+            <a:avLst/>
+          </a:prstGeom>
+          <a:noFill/>
+        </p:spPr>
+        <p:txBody>
+          <a:bodyPr wrap="square"/>
+          <a:lstStyle/>
+          <a:p>
+            <a:pPr algn="l">
+              <a:spcBef>
+                <a:spcPts val="0"/>
+              </a:spcBef>
+              <a:spcAft>
+                <a:spcPts val="600"/>
+              </a:spcAft>
+            </a:pPr>
+            <a:r>
+              <a:rPr sz="1200" b="1" i="0">
+                <a:solidFill>
+                  <a:srgbClr val="0B1F3A"/>
+                </a:solidFill>
+                <a:latin typeface="Calibri"/>
+              </a:rPr>
+              <a:t>v0 pre-Propose checklist — encode into Reviewer agent (days 1–30)</a:t>
+            </a:r>
+          </a:p>
+        </p:txBody>
+      </p:sp>
+      <p:sp>
+        <p:nvSpPr>
+          <p:cNvPr id="10" name="Rounded Rectangle 9"/>
+          <p:cNvSpPr/>
+          <p:nvPr/>
+        </p:nvSpPr>
+        <p:spPr>
+          <a:xfrm>
+            <a:off x="457200" y="3675887"/>
+            <a:ext cx="3657600" cy="2697480"/>
+          </a:xfrm>
+          <a:prstGeom prst="roundRect">
+            <a:avLst>
+              <a:gd name="adj" fmla="val 6000"/>
+            </a:avLst>
+          </a:prstGeom>
+          <a:solidFill>
+            <a:srgbClr val="FFFFFF"/>
+          </a:solidFill>
+          <a:ln w="12700">
+            <a:solidFill>
+              <a:srgbClr val="DEE3E9"/>
+            </a:solidFill>
+          </a:ln>
+        </p:spPr>
+        <p:style>
+          <a:lnRef idx="1">
+            <a:schemeClr val="accent1"/>
+          </a:lnRef>
+          <a:fillRef idx="3">
+            <a:schemeClr val="accent1"/>
+          </a:fillRef>
+          <a:effectRef idx="2">
+            <a:schemeClr val="accent1"/>
+          </a:effectRef>
+          <a:fontRef idx="minor">
+            <a:schemeClr val="lt1"/>
+          </a:fontRef>
+        </p:style>
+        <p:txBody>
+          <a:bodyPr rtlCol="0" anchor="ctr"/>
+          <a:lstStyle/>
+          <a:p>
+            <a:pPr algn="ctr"/>
+          </a:p>
+        </p:txBody>
+      </p:sp>
+      <p:sp>
+        <p:nvSpPr>
+          <p:cNvPr id="11" name="Rectangle 10"/>
+          <p:cNvSpPr/>
+          <p:nvPr/>
+        </p:nvSpPr>
+        <p:spPr>
+          <a:xfrm>
+            <a:off x="457200" y="3675887"/>
+            <a:ext cx="3657600" cy="384048"/>
+          </a:xfrm>
+          <a:prstGeom prst="rect">
+            <a:avLst/>
+          </a:prstGeom>
+          <a:solidFill>
+            <a:srgbClr val="0F6E6E"/>
+          </a:solidFill>
+          <a:ln>
+            <a:noFill/>
+          </a:ln>
+        </p:spPr>
+        <p:style>
+          <a:lnRef idx="1">
+            <a:schemeClr val="accent1"/>
+          </a:lnRef>
+          <a:fillRef idx="3">
+            <a:schemeClr val="accent1"/>
+          </a:fillRef>
+          <a:effectRef idx="2">
+            <a:schemeClr val="accent1"/>
+          </a:effectRef>
+          <a:fontRef idx="minor">
+            <a:schemeClr val="lt1"/>
+          </a:fontRef>
+        </p:style>
+        <p:txBody>
+          <a:bodyPr rtlCol="0" anchor="ctr"/>
+          <a:lstStyle/>
+          <a:p>
+            <a:pPr algn="ctr"/>
+          </a:p>
+        </p:txBody>
+      </p:sp>
+      <p:sp>
+        <p:nvSpPr>
+          <p:cNvPr id="12" name="TextBox 11"/>
+          <p:cNvSpPr txBox="1"/>
+          <p:nvPr/>
+        </p:nvSpPr>
+        <p:spPr>
+          <a:xfrm>
+            <a:off x="585216" y="3730752"/>
+            <a:ext cx="3401568" cy="292608"/>
+          </a:xfrm>
+          <a:prstGeom prst="rect">
+            <a:avLst/>
+          </a:prstGeom>
+          <a:noFill/>
+        </p:spPr>
+        <p:txBody>
+          <a:bodyPr wrap="square"/>
+          <a:lstStyle/>
+          <a:p>
+            <a:pPr algn="l">
+              <a:spcBef>
+                <a:spcPts val="0"/>
+              </a:spcBef>
+              <a:spcAft>
+                <a:spcPts val="600"/>
+              </a:spcAft>
+            </a:pPr>
+            <a:r>
+              <a:rPr sz="1300" b="1" i="0">
+                <a:solidFill>
+                  <a:srgbClr val="FFFFFF"/>
+                </a:solidFill>
+                <a:latin typeface="Calibri"/>
+              </a:rPr>
+              <a:t>GM</a:t>
+            </a:r>
+          </a:p>
+        </p:txBody>
+      </p:sp>
+      <p:sp>
+        <p:nvSpPr>
+          <p:cNvPr id="13" name="TextBox 12"/>
+          <p:cNvSpPr txBox="1"/>
+          <p:nvPr/>
+        </p:nvSpPr>
+        <p:spPr>
+          <a:xfrm>
+            <a:off x="585216" y="4133087"/>
+            <a:ext cx="3401568" cy="2148840"/>
+          </a:xfrm>
+          <a:prstGeom prst="rect">
+            <a:avLst/>
+          </a:prstGeom>
+          <a:noFill/>
+        </p:spPr>
+        <p:txBody>
+          <a:bodyPr wrap="square">
+            <a:spAutoFit/>
+          </a:bodyPr>
+          <a:lstStyle/>
+          <a:p>
+            <a:pPr algn="l">
+              <a:spcBef>
+                <a:spcPts val="0"/>
+              </a:spcBef>
+              <a:spcAft>
+                <a:spcPts val="600"/>
+              </a:spcAft>
+            </a:pPr>
+            <a:r>
+              <a:rPr sz="1100" b="0" i="0">
+                <a:solidFill>
+                  <a:srgbClr val="3A4758"/>
+                </a:solidFill>
+                <a:latin typeface="Calibri"/>
+              </a:rPr>
+              <a:t>▸  Propose (not Send); internally released</a:t>
+            </a:r>
+          </a:p>
+          <a:p>
+            <a:pPr algn="l">
+              <a:spcBef>
+                <a:spcPts val="0"/>
+              </a:spcBef>
+              <a:spcAft>
+                <a:spcPts val="600"/>
+              </a:spcAft>
+            </a:pPr>
+            <a:r>
+              <a:rPr sz="1100" b="0" i="0">
+                <a:solidFill>
+                  <a:srgbClr val="3A4758"/>
+                </a:solidFill>
+                <a:latin typeface="Calibri"/>
+              </a:rPr>
+              <a:t>▸  Correct GM org unit / plant recipient</a:t>
+            </a:r>
+          </a:p>
+          <a:p>
+            <a:pPr algn="l">
+              <a:spcBef>
+                <a:spcPts val="0"/>
+              </a:spcBef>
+              <a:spcAft>
+                <a:spcPts val="600"/>
+              </a:spcAft>
+            </a:pPr>
+            <a:r>
+              <a:rPr sz="1100" b="0" i="0">
+                <a:solidFill>
+                  <a:srgbClr val="3A4758"/>
+                </a:solidFill>
+                <a:latin typeface="Calibri"/>
+              </a:rPr>
+              <a:t>▸  Part number + description on recipient tab</a:t>
+            </a:r>
+          </a:p>
+          <a:p>
+            <a:pPr algn="l">
+              <a:spcBef>
+                <a:spcPts val="0"/>
+              </a:spcBef>
+              <a:spcAft>
+                <a:spcPts val="600"/>
+              </a:spcAft>
+            </a:pPr>
+            <a:r>
+              <a:rPr sz="1100" b="0" i="0">
+                <a:solidFill>
+                  <a:srgbClr val="3A4758"/>
+                </a:solidFill>
+                <a:latin typeface="Calibri"/>
+              </a:rPr>
+              <a:t>▸  Weight within GM tolerance; GMW3059 clean</a:t>
+            </a:r>
+          </a:p>
+          <a:p>
+            <a:pPr algn="l">
+              <a:spcBef>
+                <a:spcPts val="0"/>
+              </a:spcBef>
+              <a:spcAft>
+                <a:spcPts val="600"/>
+              </a:spcAft>
+            </a:pPr>
+            <a:r>
+              <a:rPr sz="1100" b="0" i="0">
+                <a:solidFill>
+                  <a:srgbClr val="3A4758"/>
+                </a:solidFill>
+                <a:latin typeface="Calibri"/>
+              </a:rPr>
+              <a:t>▸  Forwarding allowed if pass-through; no dummy children</a:t>
+            </a:r>
+          </a:p>
+        </p:txBody>
+      </p:sp>
+      <p:sp>
+        <p:nvSpPr>
+          <p:cNvPr id="14" name="Rounded Rectangle 13"/>
+          <p:cNvSpPr/>
+          <p:nvPr/>
+        </p:nvSpPr>
+        <p:spPr>
+          <a:xfrm>
+            <a:off x="4251960" y="3675887"/>
+            <a:ext cx="3657600" cy="2697480"/>
+          </a:xfrm>
+          <a:prstGeom prst="roundRect">
+            <a:avLst>
+              <a:gd name="adj" fmla="val 6000"/>
+            </a:avLst>
+          </a:prstGeom>
+          <a:solidFill>
+            <a:srgbClr val="FFFFFF"/>
+          </a:solidFill>
+          <a:ln w="12700">
+            <a:solidFill>
+              <a:srgbClr val="DEE3E9"/>
+            </a:solidFill>
+          </a:ln>
+        </p:spPr>
+        <p:style>
+          <a:lnRef idx="1">
+            <a:schemeClr val="accent1"/>
+          </a:lnRef>
+          <a:fillRef idx="3">
+            <a:schemeClr val="accent1"/>
+          </a:fillRef>
+          <a:effectRef idx="2">
+            <a:schemeClr val="accent1"/>
+          </a:effectRef>
+          <a:fontRef idx="minor">
+            <a:schemeClr val="lt1"/>
+          </a:fontRef>
+        </p:style>
+        <p:txBody>
+          <a:bodyPr rtlCol="0" anchor="ctr"/>
+          <a:lstStyle/>
+          <a:p>
+            <a:pPr algn="ctr"/>
+          </a:p>
+        </p:txBody>
+      </p:sp>
+      <p:sp>
+        <p:nvSpPr>
+          <p:cNvPr id="15" name="Rectangle 14"/>
+          <p:cNvSpPr/>
+          <p:nvPr/>
+        </p:nvSpPr>
+        <p:spPr>
+          <a:xfrm>
+            <a:off x="4251960" y="3675887"/>
+            <a:ext cx="3657600" cy="384048"/>
+          </a:xfrm>
+          <a:prstGeom prst="rect">
+            <a:avLst/>
+          </a:prstGeom>
+          <a:solidFill>
+            <a:srgbClr val="2C5F8A"/>
+          </a:solidFill>
+          <a:ln>
+            <a:noFill/>
+          </a:ln>
+        </p:spPr>
+        <p:style>
+          <a:lnRef idx="1">
+            <a:schemeClr val="accent1"/>
+          </a:lnRef>
+          <a:fillRef idx="3">
+            <a:schemeClr val="accent1"/>
+          </a:fillRef>
+          <a:effectRef idx="2">
+            <a:schemeClr val="accent1"/>
+          </a:effectRef>
+          <a:fontRef idx="minor">
+            <a:schemeClr val="lt1"/>
+          </a:fontRef>
+        </p:style>
+        <p:txBody>
+          <a:bodyPr rtlCol="0" anchor="ctr"/>
+          <a:lstStyle/>
+          <a:p>
+            <a:pPr algn="ctr"/>
+          </a:p>
+        </p:txBody>
+      </p:sp>
+      <p:sp>
+        <p:nvSpPr>
+          <p:cNvPr id="16" name="TextBox 15"/>
+          <p:cNvSpPr txBox="1"/>
+          <p:nvPr/>
+        </p:nvSpPr>
+        <p:spPr>
+          <a:xfrm>
+            <a:off x="4379976" y="3730752"/>
+            <a:ext cx="3401568" cy="292608"/>
+          </a:xfrm>
+          <a:prstGeom prst="rect">
+            <a:avLst/>
+          </a:prstGeom>
+          <a:noFill/>
+        </p:spPr>
+        <p:txBody>
+          <a:bodyPr wrap="square"/>
+          <a:lstStyle/>
+          <a:p>
+            <a:pPr algn="l">
+              <a:spcBef>
+                <a:spcPts val="0"/>
+              </a:spcBef>
+              <a:spcAft>
+                <a:spcPts val="600"/>
+              </a:spcAft>
+            </a:pPr>
+            <a:r>
+              <a:rPr sz="1300" b="1" i="0">
+                <a:solidFill>
+                  <a:srgbClr val="FFFFFF"/>
+                </a:solidFill>
+                <a:latin typeface="Calibri"/>
+              </a:rPr>
+              <a:t>VW</a:t>
+            </a:r>
+          </a:p>
+        </p:txBody>
+      </p:sp>
+      <p:sp>
+        <p:nvSpPr>
+          <p:cNvPr id="17" name="TextBox 16"/>
+          <p:cNvSpPr txBox="1"/>
+          <p:nvPr/>
+        </p:nvSpPr>
+        <p:spPr>
+          <a:xfrm>
+            <a:off x="4379976" y="4133087"/>
+            <a:ext cx="3401568" cy="2148840"/>
+          </a:xfrm>
+          <a:prstGeom prst="rect">
+            <a:avLst/>
+          </a:prstGeom>
+          <a:noFill/>
+        </p:spPr>
+        <p:txBody>
+          <a:bodyPr wrap="square">
+            <a:spAutoFit/>
+          </a:bodyPr>
+          <a:lstStyle/>
+          <a:p>
+            <a:pPr algn="l">
+              <a:spcBef>
+                <a:spcPts val="0"/>
+              </a:spcBef>
+              <a:spcAft>
+                <a:spcPts val="600"/>
+              </a:spcAft>
+            </a:pPr>
+            <a:r>
+              <a:rPr sz="1100" b="0" i="0">
+                <a:solidFill>
+                  <a:srgbClr val="3A4758"/>
+                </a:solidFill>
+                <a:latin typeface="Calibri"/>
+              </a:rPr>
+              <a:t>▸  VW 91101 + Konzern IMDS instructions</a:t>
+            </a:r>
+          </a:p>
+          <a:p>
+            <a:pPr algn="l">
+              <a:spcBef>
+                <a:spcPts val="0"/>
+              </a:spcBef>
+              <a:spcAft>
+                <a:spcPts val="600"/>
+              </a:spcAft>
+            </a:pPr>
+            <a:r>
+              <a:rPr sz="1100" b="0" i="0">
+                <a:solidFill>
+                  <a:srgbClr val="3A4758"/>
+                </a:solidFill>
+                <a:latin typeface="Calibri"/>
+              </a:rPr>
+              <a:t>▸  Correct plant / org ID on recipient</a:t>
+            </a:r>
+          </a:p>
+          <a:p>
+            <a:pPr algn="l">
+              <a:spcBef>
+                <a:spcPts val="0"/>
+              </a:spcBef>
+              <a:spcAft>
+                <a:spcPts val="600"/>
+              </a:spcAft>
+            </a:pPr>
+            <a:r>
+              <a:rPr sz="1100" b="0" i="0">
+                <a:solidFill>
+                  <a:srgbClr val="3A4758"/>
+                </a:solidFill>
+                <a:latin typeface="Calibri"/>
+              </a:rPr>
+              <a:t>▸  Part naming per VW guide; sibling rules</a:t>
+            </a:r>
+          </a:p>
+          <a:p>
+            <a:pPr algn="l">
+              <a:spcBef>
+                <a:spcPts val="0"/>
+              </a:spcBef>
+              <a:spcAft>
+                <a:spcPts val="600"/>
+              </a:spcAft>
+            </a:pPr>
+            <a:r>
+              <a:rPr sz="1100" b="0" i="0">
+                <a:solidFill>
+                  <a:srgbClr val="3A4758"/>
+                </a:solidFill>
+                <a:latin typeface="Calibri"/>
+              </a:rPr>
+              <a:t>▸  Polymer marking / process fields if required</a:t>
+            </a:r>
+          </a:p>
+          <a:p>
+            <a:pPr algn="l">
+              <a:spcBef>
+                <a:spcPts val="0"/>
+              </a:spcBef>
+              <a:spcAft>
+                <a:spcPts val="600"/>
+              </a:spcAft>
+            </a:pPr>
+            <a:r>
+              <a:rPr sz="1100" b="0" i="0">
+                <a:solidFill>
+                  <a:srgbClr val="3A4758"/>
+                </a:solidFill>
+                <a:latin typeface="Calibri"/>
+              </a:rPr>
+              <a:t>▸  VW pack pre-flight — no reds before Propose</a:t>
+            </a:r>
+          </a:p>
+        </p:txBody>
+      </p:sp>
+      <p:sp>
+        <p:nvSpPr>
+          <p:cNvPr id="18" name="Rounded Rectangle 17"/>
+          <p:cNvSpPr/>
+          <p:nvPr/>
+        </p:nvSpPr>
+        <p:spPr>
+          <a:xfrm>
+            <a:off x="8046720" y="3675887"/>
+            <a:ext cx="3657600" cy="2697480"/>
+          </a:xfrm>
+          <a:prstGeom prst="roundRect">
+            <a:avLst>
+              <a:gd name="adj" fmla="val 6000"/>
+            </a:avLst>
+          </a:prstGeom>
+          <a:solidFill>
+            <a:srgbClr val="FFFFFF"/>
+          </a:solidFill>
+          <a:ln w="12700">
+            <a:solidFill>
+              <a:srgbClr val="DEE3E9"/>
+            </a:solidFill>
+          </a:ln>
+        </p:spPr>
+        <p:style>
+          <a:lnRef idx="1">
+            <a:schemeClr val="accent1"/>
+          </a:lnRef>
+          <a:fillRef idx="3">
+            <a:schemeClr val="accent1"/>
+          </a:fillRef>
+          <a:effectRef idx="2">
+            <a:schemeClr val="accent1"/>
+          </a:effectRef>
+          <a:fontRef idx="minor">
+            <a:schemeClr val="lt1"/>
+          </a:fontRef>
+        </p:style>
+        <p:txBody>
+          <a:bodyPr rtlCol="0" anchor="ctr"/>
+          <a:lstStyle/>
+          <a:p>
+            <a:pPr algn="ctr"/>
+          </a:p>
+        </p:txBody>
+      </p:sp>
+      <p:sp>
+        <p:nvSpPr>
+          <p:cNvPr id="19" name="Rectangle 18"/>
+          <p:cNvSpPr/>
+          <p:nvPr/>
+        </p:nvSpPr>
+        <p:spPr>
+          <a:xfrm>
+            <a:off x="8046720" y="3675887"/>
+            <a:ext cx="3657600" cy="384048"/>
+          </a:xfrm>
+          <a:prstGeom prst="rect">
+            <a:avLst/>
+          </a:prstGeom>
+          <a:solidFill>
+            <a:srgbClr val="C96A2C"/>
+          </a:solidFill>
+          <a:ln>
+            <a:noFill/>
+          </a:ln>
+        </p:spPr>
+        <p:style>
+          <a:lnRef idx="1">
+            <a:schemeClr val="accent1"/>
+          </a:lnRef>
+          <a:fillRef idx="3">
+            <a:schemeClr val="accent1"/>
+          </a:fillRef>
+          <a:effectRef idx="2">
+            <a:schemeClr val="accent1"/>
+          </a:effectRef>
+          <a:fontRef idx="minor">
+            <a:schemeClr val="lt1"/>
+          </a:fontRef>
+        </p:style>
+        <p:txBody>
+          <a:bodyPr rtlCol="0" anchor="ctr"/>
+          <a:lstStyle/>
+          <a:p>
+            <a:pPr algn="ctr"/>
+          </a:p>
+        </p:txBody>
+      </p:sp>
+      <p:sp>
+        <p:nvSpPr>
+          <p:cNvPr id="20" name="TextBox 19"/>
+          <p:cNvSpPr txBox="1"/>
+          <p:nvPr/>
+        </p:nvSpPr>
+        <p:spPr>
+          <a:xfrm>
+            <a:off x="8174736" y="3730752"/>
+            <a:ext cx="3401568" cy="292608"/>
+          </a:xfrm>
+          <a:prstGeom prst="rect">
+            <a:avLst/>
+          </a:prstGeom>
+          <a:noFill/>
+        </p:spPr>
+        <p:txBody>
+          <a:bodyPr wrap="square"/>
+          <a:lstStyle/>
+          <a:p>
+            <a:pPr algn="l">
+              <a:spcBef>
+                <a:spcPts val="0"/>
+              </a:spcBef>
+              <a:spcAft>
+                <a:spcPts val="600"/>
+              </a:spcAft>
+            </a:pPr>
+            <a:r>
+              <a:rPr sz="1300" b="1" i="0">
+                <a:solidFill>
+                  <a:srgbClr val="FFFFFF"/>
+                </a:solidFill>
+                <a:latin typeface="Calibri"/>
+              </a:rPr>
+              <a:t>Ford</a:t>
+            </a:r>
+          </a:p>
+        </p:txBody>
+      </p:sp>
+      <p:sp>
+        <p:nvSpPr>
+          <p:cNvPr id="21" name="TextBox 20"/>
+          <p:cNvSpPr txBox="1"/>
+          <p:nvPr/>
+        </p:nvSpPr>
+        <p:spPr>
+          <a:xfrm>
+            <a:off x="8174736" y="4133087"/>
+            <a:ext cx="3401568" cy="2148840"/>
+          </a:xfrm>
+          <a:prstGeom prst="rect">
+            <a:avLst/>
+          </a:prstGeom>
+          <a:noFill/>
+        </p:spPr>
+        <p:txBody>
+          <a:bodyPr wrap="square">
+            <a:spAutoFit/>
+          </a:bodyPr>
+          <a:lstStyle/>
+          <a:p>
+            <a:pPr algn="l">
+              <a:spcBef>
+                <a:spcPts val="0"/>
+              </a:spcBef>
+              <a:spcAft>
+                <a:spcPts val="600"/>
+              </a:spcAft>
+            </a:pPr>
+            <a:r>
+              <a:rPr sz="1100" b="0" i="0">
+                <a:solidFill>
+                  <a:srgbClr val="3A4758"/>
+                </a:solidFill>
+                <a:latin typeface="Calibri"/>
+              </a:rPr>
+              <a:t>▸  Ford RSMS substance compliance</a:t>
+            </a:r>
+          </a:p>
+          <a:p>
+            <a:pPr algn="l">
+              <a:spcBef>
+                <a:spcPts val="0"/>
+              </a:spcBef>
+              <a:spcAft>
+                <a:spcPts val="600"/>
+              </a:spcAft>
+            </a:pPr>
+            <a:r>
+              <a:rPr sz="1100" b="0" i="0">
+                <a:solidFill>
+                  <a:srgbClr val="3A4758"/>
+                </a:solidFill>
+                <a:latin typeface="Calibri"/>
+              </a:rPr>
+              <a:t>▸  Supplier code + part number pairing</a:t>
+            </a:r>
+          </a:p>
+          <a:p>
+            <a:pPr algn="l">
+              <a:spcBef>
+                <a:spcPts val="0"/>
+              </a:spcBef>
+              <a:spcAft>
+                <a:spcPts val="600"/>
+              </a:spcAft>
+            </a:pPr>
+            <a:r>
+              <a:rPr sz="1100" b="0" i="0">
+                <a:solidFill>
+                  <a:srgbClr val="3A4758"/>
+                </a:solidFill>
+                <a:latin typeface="Calibri"/>
+              </a:rPr>
+              <a:t>▸  Legacy / EOP flags if applicable</a:t>
+            </a:r>
+          </a:p>
+          <a:p>
+            <a:pPr algn="l">
+              <a:spcBef>
+                <a:spcPts val="0"/>
+              </a:spcBef>
+              <a:spcAft>
+                <a:spcPts val="600"/>
+              </a:spcAft>
+            </a:pPr>
+            <a:r>
+              <a:rPr sz="1100" b="0" i="0">
+                <a:solidFill>
+                  <a:srgbClr val="3A4758"/>
+                </a:solidFill>
+                <a:latin typeface="Calibri"/>
+              </a:rPr>
+              <a:t>▸  Correct Ford org unit; tree vs BOM</a:t>
+            </a:r>
+          </a:p>
+          <a:p>
+            <a:pPr algn="l">
+              <a:spcBef>
+                <a:spcPts val="0"/>
+              </a:spcBef>
+              <a:spcAft>
+                <a:spcPts val="600"/>
+              </a:spcAft>
+            </a:pPr>
+            <a:r>
+              <a:rPr sz="1100" b="0" i="0">
+                <a:solidFill>
+                  <a:srgbClr val="3A4758"/>
+                </a:solidFill>
+                <a:latin typeface="Calibri"/>
+              </a:rPr>
+              <a:t>▸  Ford pack pre-flight — no reds before Propose</a:t>
+            </a:r>
+          </a:p>
+        </p:txBody>
+      </p:sp>
+      <p:sp>
+        <p:nvSpPr>
+          <p:cNvPr id="22" name="TextBox 21"/>
+          <p:cNvSpPr txBox="1"/>
+          <p:nvPr/>
+        </p:nvSpPr>
+        <p:spPr>
+          <a:xfrm>
+            <a:off x="457200" y="6419088"/>
+            <a:ext cx="11247120" cy="201168"/>
+          </a:xfrm>
+          <a:prstGeom prst="rect">
+            <a:avLst/>
+          </a:prstGeom>
+          <a:noFill/>
+        </p:spPr>
+        <p:txBody>
+          <a:bodyPr wrap="square"/>
+          <a:lstStyle/>
+          <a:p>
+            <a:pPr algn="l">
+              <a:spcBef>
+                <a:spcPts val="0"/>
+              </a:spcBef>
+              <a:spcAft>
+                <a:spcPts val="600"/>
+              </a:spcAft>
+            </a:pPr>
+            <a:r>
+              <a:rPr sz="1000" b="0" i="0">
+                <a:solidFill>
+                  <a:srgbClr val="6A7584"/>
+                </a:solidFill>
+                <a:latin typeface="Calibri"/>
+              </a:rPr>
+              <a:t>Predco vendor-reported (−89% rejects, −72% cycle): industry proof only — not our ROI. HR: role shifts from inbox clerk to OEM-rule owner + exception judgment.</a:t>
+            </a:r>
+          </a:p>
+        </p:txBody>
+      </p:sp>
+      <p:sp>
+        <p:nvSpPr>
+          <p:cNvPr id="23" name="Rectangle 22"/>
+          <p:cNvSpPr/>
+          <p:nvPr/>
+        </p:nvSpPr>
+        <p:spPr>
+          <a:xfrm>
+            <a:off x="0" y="6656832"/>
+            <a:ext cx="12191695" cy="201168"/>
+          </a:xfrm>
+          <a:prstGeom prst="rect">
+            <a:avLst/>
+          </a:prstGeom>
+          <a:solidFill>
+            <a:srgbClr val="F5F7F9"/>
+          </a:solidFill>
+          <a:ln>
+            <a:noFill/>
+          </a:ln>
+        </p:spPr>
+        <p:style>
+          <a:lnRef idx="1">
+            <a:schemeClr val="accent1"/>
+          </a:lnRef>
+          <a:fillRef idx="3">
+            <a:schemeClr val="accent1"/>
+          </a:fillRef>
+          <a:effectRef idx="2">
+            <a:schemeClr val="accent1"/>
+          </a:effectRef>
+          <a:fontRef idx="minor">
+            <a:schemeClr val="lt1"/>
+          </a:fontRef>
+        </p:style>
+        <p:txBody>
+          <a:bodyPr rtlCol="0" anchor="ctr"/>
+          <a:lstStyle/>
+          <a:p>
+            <a:pPr algn="ctr"/>
+          </a:p>
+        </p:txBody>
+      </p:sp>
+      <p:sp>
+        <p:nvSpPr>
+          <p:cNvPr id="24" name="Rectangle 23"/>
+          <p:cNvSpPr/>
+          <p:nvPr/>
+        </p:nvSpPr>
+        <p:spPr>
+          <a:xfrm>
+            <a:off x="0" y="6656832"/>
+            <a:ext cx="12191695" cy="12700"/>
+          </a:xfrm>
+          <a:prstGeom prst="rect">
+            <a:avLst/>
+          </a:prstGeom>
+          <a:solidFill>
+            <a:srgbClr val="C4A35A"/>
+          </a:solidFill>
+          <a:ln>
+            <a:noFill/>
+          </a:ln>
+        </p:spPr>
+        <p:style>
+          <a:lnRef idx="1">
+            <a:schemeClr val="accent1"/>
+          </a:lnRef>
+          <a:fillRef idx="3">
+            <a:schemeClr val="accent1"/>
+          </a:fillRef>
+          <a:effectRef idx="2">
+            <a:schemeClr val="accent1"/>
+          </a:effectRef>
+          <a:fontRef idx="minor">
+            <a:schemeClr val="lt1"/>
+          </a:fontRef>
+        </p:style>
+        <p:txBody>
+          <a:bodyPr rtlCol="0" anchor="ctr"/>
+          <a:lstStyle/>
+          <a:p>
+            <a:pPr algn="ctr"/>
+          </a:p>
+        </p:txBody>
+      </p:sp>
+      <p:sp>
+        <p:nvSpPr>
+          <p:cNvPr id="25" name="TextBox 24"/>
+          <p:cNvSpPr txBox="1"/>
+          <p:nvPr/>
+        </p:nvSpPr>
+        <p:spPr>
+          <a:xfrm>
+            <a:off x="411480" y="6675120"/>
+            <a:ext cx="8961120" cy="164592"/>
+          </a:xfrm>
+          <a:prstGeom prst="rect">
+            <a:avLst/>
+          </a:prstGeom>
+          <a:noFill/>
+        </p:spPr>
+        <p:txBody>
+          <a:bodyPr wrap="square"/>
+          <a:lstStyle/>
+          <a:p>
+            <a:pPr algn="l">
+              <a:spcBef>
+                <a:spcPts val="0"/>
+              </a:spcBef>
+              <a:spcAft>
+                <a:spcPts val="600"/>
+              </a:spcAft>
+            </a:pPr>
+            <a:r>
+              <a:rPr sz="900" b="0" i="0">
+                <a:solidFill>
+                  <a:srgbClr val="8A96A4"/>
+                </a:solidFill>
+                <a:latin typeface="Calibri"/>
+              </a:rPr>
+              <a:t>INTERNAL CONFIDENTIAL  ·  Supplier Quality  ·  Agentic MDS briefing  ·  August 2026</a:t>
+            </a:r>
+          </a:p>
+        </p:txBody>
+      </p:sp>
+      <p:sp>
+        <p:nvSpPr>
+          <p:cNvPr id="26" name="TextBox 25"/>
+          <p:cNvSpPr txBox="1"/>
+          <p:nvPr/>
+        </p:nvSpPr>
+        <p:spPr>
+          <a:xfrm>
+            <a:off x="10241280" y="6675120"/>
+            <a:ext cx="1554480" cy="164592"/>
+          </a:xfrm>
+          <a:prstGeom prst="rect">
+            <a:avLst/>
+          </a:prstGeom>
+          <a:noFill/>
+        </p:spPr>
+        <p:txBody>
+          <a:bodyPr wrap="square"/>
+          <a:lstStyle/>
+          <a:p>
+            <a:pPr algn="r">
+              <a:spcBef>
+                <a:spcPts val="0"/>
+              </a:spcBef>
+              <a:spcAft>
+                <a:spcPts val="600"/>
+              </a:spcAft>
+            </a:pPr>
+            <a:r>
+              <a:rPr sz="900" b="0" i="0">
+                <a:solidFill>
+                  <a:srgbClr val="8A96A4"/>
+                </a:solidFill>
+                <a:latin typeface="Calibri"/>
+              </a:rPr>
+              <a:t>13  /  13</a:t>
             </a:r>
           </a:p>
         </p:txBody>
@@ -10740,7 +13072,7 @@
                 </a:solidFill>
                 <a:latin typeface="Calibri"/>
               </a:rPr>
-              <a:t>2  /  12</a:t>
+              <a:t>2  /  13</a:t>
             </a:r>
           </a:p>
         </p:txBody>
@@ -11827,7 +14159,7 @@
                 </a:solidFill>
                 <a:latin typeface="Calibri"/>
               </a:rPr>
-              <a:t>3  /  12</a:t>
+              <a:t>3  /  13</a:t>
             </a:r>
           </a:p>
         </p:txBody>
@@ -13480,7 +15812,7 @@
                 </a:solidFill>
                 <a:latin typeface="Calibri"/>
               </a:rPr>
-              <a:t>4  /  12</a:t>
+              <a:t>4  /  13</a:t>
             </a:r>
           </a:p>
         </p:txBody>
@@ -14713,7 +17045,7 @@
                 </a:solidFill>
                 <a:latin typeface="Calibri"/>
               </a:rPr>
-              <a:t>5  /  12</a:t>
+              <a:t>5  /  13</a:t>
             </a:r>
           </a:p>
         </p:txBody>
@@ -16361,7 +18693,7 @@
                 </a:solidFill>
                 <a:latin typeface="Calibri"/>
               </a:rPr>
-              <a:t>6  /  12</a:t>
+              <a:t>6  /  13</a:t>
             </a:r>
           </a:p>
         </p:txBody>
@@ -17595,7 +19927,7 @@
                 </a:solidFill>
                 <a:latin typeface="Calibri"/>
               </a:rPr>
-              <a:t>7  /  12</a:t>
+              <a:t>7  /  13</a:t>
             </a:r>
           </a:p>
         </p:txBody>
@@ -19180,7 +21512,7 @@
                 </a:solidFill>
                 <a:latin typeface="Calibri"/>
               </a:rPr>
-              <a:t>8  /  12</a:t>
+              <a:t>8  /  13</a:t>
             </a:r>
           </a:p>
         </p:txBody>
@@ -20064,7 +22396,7 @@
                 </a:solidFill>
                 <a:latin typeface="Calibri"/>
               </a:rPr>
-              <a:t>9  /  12</a:t>
+              <a:t>9  /  13</a:t>
             </a:r>
           </a:p>
         </p:txBody>

</xml_diff>